<commit_message>
Cover slogan highlights dual-trajectory calibration; weather-forecast metaphor (v12)
Co-Authored-By: Claude Opus 5.5 <noreply@anthropic.com>
Claude-Session: https://claude.ai/code/session_01NTagjVHGZdXLvG9VCNzDRT
</commit_message>
<xml_diff>
--- a/slides/Vitoma_BP_part1_team.pptx
+++ b/slides/Vitoma_BP_part1_team.pptx
@@ -113,17 +113,17 @@
   <p:extLst>
     <p:ext uri="{521415D9-36F7-43E2-AB2F-B90AF26B5E84}">
       <p14:sectionLst xmlns:p14="http://schemas.microsoft.com/office/powerpoint/2010/main">
-        <p14:section name="封面" id="{12ee3b46-d46c-94b5-c236-256d3f7003d1}">
+        <p14:section name="封面" id="{a2803719-65f1-6f39-7b31-182d015804a9}">
           <p14:sldIdLst>
             <p14:sldId id="256"/>
           </p14:sldIdLst>
         </p14:section>
-        <p14:section name="目录" id="{e0ef32e9-d7f2-747f-6506-d997ae8ca35e}">
+        <p14:section name="目录" id="{49ca34a8-416e-64ec-4702-f77d7f79b61d}">
           <p14:sldIdLst>
             <p14:sldId id="257"/>
           </p14:sldIdLst>
         </p14:section>
-        <p14:section name="第一部分 为什么要做" id="{92e76903-7bff-45ce-a718-4f4bc348dcb6}">
+        <p14:section name="第一部分 为什么要做" id="{cef22f5b-50a6-25be-2adf-bb872da9e5ea}">
           <p14:sldIdLst>
             <p14:sldId id="258"/>
             <p14:sldId id="259"/>
@@ -131,7 +131,7 @@
             <p14:sldId id="261"/>
           </p14:sldIdLst>
         </p14:section>
-        <p14:section name="第二部分 为什么我们能做成" id="{bbb34a75-be22-908a-ef99-93fe88c6412c}">
+        <p14:section name="第二部分 为什么我们能做成" id="{ebb9c49c-60d4-3c05-82e3-defe5dce84c7}">
           <p14:sldIdLst>
             <p14:sldId id="262"/>
           </p14:sldIdLst>
@@ -1923,7 +1923,7 @@
                   <a:schemeClr val="bg1"/>
                 </a:solidFill>
               </a:rPr>
-              <a:t>让每一次治疗，先在患者自己的类器官上预演</a:t>
+              <a:t>患者与类器官双轨校准，预见肿瘤的下一步</a:t>
             </a:r>
             <a:endParaRPr lang="en-US" sz="3400" dirty="0"/>
           </a:p>
@@ -1962,7 +1962,7 @@
                 <a:ea typeface="Arial" pitchFamily="34" charset="-122"/>
                 <a:cs typeface="Arial" pitchFamily="34" charset="-120"/>
               </a:rPr>
-              <a:t>Rehearse every treatment on the patient's own organoids — before it begins.</a:t>
+              <a:t>Patient and organoid, calibrated in parallel — to foresee the tumor's next move.</a:t>
             </a:r>
             <a:endParaRPr lang="en-US" sz="1600" dirty="0"/>
           </a:p>

</xml_diff>

<commit_message>
Polish team slide and BP team section from full resumes (v13)
Co-Authored-By: Claude Opus 5.5 <noreply@anthropic.com>
Claude-Session: https://claude.ai/code/session_01NTagjVHGZdXLvG9VCNzDRT
</commit_message>
<xml_diff>
--- a/slides/Vitoma_BP_part1_team.pptx
+++ b/slides/Vitoma_BP_part1_team.pptx
@@ -1746,8 +1746,8 @@
         </p:nvSpPr>
         <p:spPr>
           <a:xfrm>
-            <a:off x="1109853" y="1097280"/>
-            <a:ext cx="1417320" cy="1417320"/>
+            <a:off x="1247013" y="1024128"/>
+            <a:ext cx="1143000" cy="1143000"/>
           </a:xfrm>
           <a:prstGeom prst="ellipse">
             <a:avLst/>
@@ -1767,7 +1767,7 @@
           <a:p>
             <a:pPr algn="ctr">
               <a:lnSpc>
-                <a:spcPct val="115000"/>
+                <a:spcPct val="112000"/>
               </a:lnSpc>
               <a:buNone/>
             </a:pPr>
@@ -1793,8 +1793,8 @@
         </p:nvSpPr>
         <p:spPr>
           <a:xfrm>
-            <a:off x="530352" y="2651760"/>
-            <a:ext cx="2576322" cy="347472"/>
+            <a:off x="530352" y="2240280"/>
+            <a:ext cx="2576322" cy="329184"/>
           </a:xfrm>
           <a:prstGeom prst="rect">
             <a:avLst/>
@@ -1809,7 +1809,7 @@
           <a:p>
             <a:pPr algn="ctr">
               <a:lnSpc>
-                <a:spcPct val="115000"/>
+                <a:spcPct val="112000"/>
               </a:lnSpc>
               <a:buNone/>
             </a:pPr>
@@ -1835,8 +1835,8 @@
         </p:nvSpPr>
         <p:spPr>
           <a:xfrm>
-            <a:off x="530352" y="2999232"/>
-            <a:ext cx="2576322" cy="292608"/>
+            <a:off x="530352" y="2560320"/>
+            <a:ext cx="2576322" cy="274320"/>
           </a:xfrm>
           <a:prstGeom prst="rect">
             <a:avLst/>
@@ -1851,7 +1851,7 @@
           <a:p>
             <a:pPr algn="ctr">
               <a:lnSpc>
-                <a:spcPct val="115000"/>
+                <a:spcPct val="112000"/>
               </a:lnSpc>
               <a:buNone/>
             </a:pPr>
@@ -1871,14 +1871,56 @@
       </p:sp>
       <p:sp>
         <p:nvSpPr>
-          <p:cNvPr id="304" name="经历 1"/>
+          <p:cNvPr id="304" name="亮点 1"/>
           <p:cNvSpPr txBox="1"/>
           <p:nvPr/>
         </p:nvSpPr>
         <p:spPr>
           <a:xfrm>
-            <a:off x="621792" y="3474720"/>
-            <a:ext cx="2439162" cy="2788920"/>
+            <a:off x="530352" y="2852928"/>
+            <a:ext cx="2576322" cy="256032"/>
+          </a:xfrm>
+          <a:prstGeom prst="rect">
+            <a:avLst/>
+          </a:prstGeom>
+          <a:noFill/>
+        </p:spPr>
+        <p:txBody>
+          <a:bodyPr wrap="square" lIns="0" tIns="0" rIns="0" bIns="0" anchor="ctr">
+            <a:noAutofit/>
+          </a:bodyPr>
+          <a:lstStyle/>
+          <a:p>
+            <a:pPr algn="ctr">
+              <a:lnSpc>
+                <a:spcPct val="112000"/>
+              </a:lnSpc>
+              <a:buNone/>
+            </a:pPr>
+            <a:r>
+              <a:rPr lang="zh-CN" altLang="en-US" sz="1050">
+                <a:solidFill>
+                  <a:srgbClr val="44546A"/>
+                </a:solidFill>
+                <a:latin typeface="微软雅黑"/>
+                <a:ea typeface="微软雅黑"/>
+                <a:cs typeface="微软雅黑"/>
+              </a:rPr>
+              <a:t>湿实验 × 数据 × AI，全链路打通</a:t>
+            </a:r>
+          </a:p>
+        </p:txBody>
+      </p:sp>
+      <p:sp>
+        <p:nvSpPr>
+          <p:cNvPr id="305" name="经历 1"/>
+          <p:cNvSpPr txBox="1"/>
+          <p:nvPr/>
+        </p:nvSpPr>
+        <p:spPr>
+          <a:xfrm>
+            <a:off x="603504" y="3246120"/>
+            <a:ext cx="2484882" cy="3063240"/>
           </a:xfrm>
           <a:prstGeom prst="rect">
             <a:avLst/>
@@ -1893,10 +1935,10 @@
           <a:p>
             <a:pPr algn="l" marL="171450" indent="-171450">
               <a:lnSpc>
-                <a:spcPct val="115000"/>
+                <a:spcPct val="112000"/>
               </a:lnSpc>
               <a:spcAft>
-                <a:spcPts val="400"/>
+                <a:spcPts val="300"/>
               </a:spcAft>
               <a:buClr>
                 <a:srgbClr val="08A6F6"/>
@@ -1905,7 +1947,18 @@
               <a:buChar char="•"/>
             </a:pPr>
             <a:r>
-              <a:rPr lang="zh-CN" altLang="en-US" sz="1100">
+              <a:rPr lang="zh-CN" altLang="en-US" sz="1000" b="1">
+                <a:solidFill>
+                  <a:srgbClr val="061F32"/>
+                </a:solidFill>
+                <a:latin typeface="微软雅黑"/>
+                <a:ea typeface="微软雅黑"/>
+                <a:cs typeface="微软雅黑"/>
+              </a:rPr>
+              <a:t>Verqura 实验室管理系统创始人</a:t>
+            </a:r>
+            <a:r>
+              <a:rPr lang="zh-CN" altLang="en-US" sz="1000">
                 <a:solidFill>
                   <a:srgbClr val="44546A"/>
                 </a:solidFill>
@@ -1913,16 +1966,16 @@
                 <a:ea typeface="微软雅黑"/>
                 <a:cs typeface="微软雅黑"/>
               </a:rPr>
-              <a:t>海德堡大学/DKFZ 发育生物学博士</a:t>
+              <a:t>：打通样本、实验与数据管理</a:t>
             </a:r>
           </a:p>
           <a:p>
             <a:pPr algn="l" marL="171450" indent="-171450">
               <a:lnSpc>
-                <a:spcPct val="115000"/>
+                <a:spcPct val="112000"/>
               </a:lnSpc>
               <a:spcAft>
-                <a:spcPts val="400"/>
+                <a:spcPts val="300"/>
               </a:spcAft>
               <a:buClr>
                 <a:srgbClr val="08A6F6"/>
@@ -1931,7 +1984,18 @@
               <a:buChar char="•"/>
             </a:pPr>
             <a:r>
-              <a:rPr lang="zh-CN" altLang="en-US" sz="1100">
+              <a:rPr lang="zh-CN" altLang="en-US" sz="1000" b="1">
+                <a:solidFill>
+                  <a:srgbClr val="061F32"/>
+                </a:solidFill>
+                <a:latin typeface="微软雅黑"/>
+                <a:ea typeface="微软雅黑"/>
+                <a:cs typeface="微软雅黑"/>
+              </a:rPr>
+              <a:t>Cell Stem Cell 2025、npj Precision Oncology 2024 作者</a:t>
+            </a:r>
+            <a:r>
+              <a:rPr lang="zh-CN" altLang="en-US" sz="1000">
                 <a:solidFill>
                   <a:srgbClr val="44546A"/>
                 </a:solidFill>
@@ -1939,16 +2003,16 @@
                 <a:ea typeface="微软雅黑"/>
                 <a:cs typeface="微软雅黑"/>
               </a:rPr>
-              <a:t>密歇根大学安娜堡分校学士</a:t>
+              <a:t>（类器官预测患者治疗响应）</a:t>
             </a:r>
           </a:p>
           <a:p>
             <a:pPr algn="l" marL="171450" indent="-171450">
               <a:lnSpc>
-                <a:spcPct val="115000"/>
+                <a:spcPct val="112000"/>
               </a:lnSpc>
               <a:spcAft>
-                <a:spcPts val="400"/>
+                <a:spcPts val="300"/>
               </a:spcAft>
               <a:buClr>
                 <a:srgbClr val="08A6F6"/>
@@ -1957,7 +2021,18 @@
               <a:buChar char="•"/>
             </a:pPr>
             <a:r>
-              <a:rPr lang="zh-CN" altLang="en-US" sz="1100">
+              <a:rPr lang="zh-CN" altLang="en-US" sz="1000" b="1">
+                <a:solidFill>
+                  <a:srgbClr val="061F32"/>
+                </a:solidFill>
+                <a:latin typeface="微软雅黑"/>
+                <a:ea typeface="微软雅黑"/>
+                <a:cs typeface="微软雅黑"/>
+              </a:rPr>
+              <a:t>精通 iPSC 脑类器官构建</a:t>
+            </a:r>
+            <a:r>
+              <a:rPr lang="zh-CN" altLang="en-US" sz="1000">
                 <a:solidFill>
                   <a:srgbClr val="44546A"/>
                 </a:solidFill>
@@ -1965,16 +2040,16 @@
                 <a:ea typeface="微软雅黑"/>
                 <a:cs typeface="微软雅黑"/>
               </a:rPr>
-              <a:t>Verqura 实验室管理系统创始人</a:t>
+              <a:t>，引进 Pașca 团队分化方案；CRISPR 基因组编辑</a:t>
             </a:r>
           </a:p>
           <a:p>
             <a:pPr algn="l" marL="171450" indent="-171450">
               <a:lnSpc>
-                <a:spcPct val="115000"/>
+                <a:spcPct val="112000"/>
               </a:lnSpc>
               <a:spcAft>
-                <a:spcPts val="400"/>
+                <a:spcPts val="300"/>
               </a:spcAft>
               <a:buClr>
                 <a:srgbClr val="08A6F6"/>
@@ -1983,7 +2058,18 @@
               <a:buChar char="•"/>
             </a:pPr>
             <a:r>
-              <a:rPr lang="zh-CN" altLang="en-US" sz="1100">
+              <a:rPr lang="zh-CN" altLang="en-US" sz="1000" b="1">
+                <a:solidFill>
+                  <a:srgbClr val="061F32"/>
+                </a:solidFill>
+                <a:latin typeface="微软雅黑"/>
+                <a:ea typeface="微软雅黑"/>
+                <a:cs typeface="微软雅黑"/>
+              </a:rPr>
+              <a:t>单细胞 RNA / ATAC 测序分析</a:t>
+            </a:r>
+            <a:r>
+              <a:rPr lang="zh-CN" altLang="en-US" sz="1000">
                 <a:solidFill>
                   <a:srgbClr val="44546A"/>
                 </a:solidFill>
@@ -1991,16 +2077,16 @@
                 <a:ea typeface="微软雅黑"/>
                 <a:cs typeface="微软雅黑"/>
               </a:rPr>
-              <a:t>精通 iPSC 脑类器官构建、CRISPR 基因组编辑与标记</a:t>
+              <a:t>；训练 YOLO / Cellpose 图像 AI 模型</a:t>
             </a:r>
           </a:p>
           <a:p>
             <a:pPr algn="l" marL="171450" indent="-171450">
               <a:lnSpc>
-                <a:spcPct val="115000"/>
+                <a:spcPct val="112000"/>
               </a:lnSpc>
               <a:spcAft>
-                <a:spcPts val="400"/>
+                <a:spcPts val="300"/>
               </a:spcAft>
               <a:buClr>
                 <a:srgbClr val="08A6F6"/>
@@ -2009,7 +2095,18 @@
               <a:buChar char="•"/>
             </a:pPr>
             <a:r>
-              <a:rPr lang="zh-CN" altLang="en-US" sz="1100">
+              <a:rPr lang="zh-CN" altLang="en-US" sz="1000" b="1">
+                <a:solidFill>
+                  <a:srgbClr val="061F32"/>
+                </a:solidFill>
+                <a:latin typeface="微软雅黑"/>
+                <a:ea typeface="微软雅黑"/>
+                <a:cs typeface="微软雅黑"/>
+              </a:rPr>
+              <a:t>海德堡大学 / DKFZ 发育生物学博士</a:t>
+            </a:r>
+            <a:r>
+              <a:rPr lang="zh-CN" altLang="en-US" sz="1000">
                 <a:solidFill>
                   <a:srgbClr val="44546A"/>
                 </a:solidFill>
@@ -2017,47 +2114,21 @@
                 <a:ea typeface="微软雅黑"/>
                 <a:cs typeface="微软雅黑"/>
               </a:rPr>
-              <a:t>单细胞测序与 AI 图像分析（YOLO / Cellpose）</a:t>
-            </a:r>
-          </a:p>
-          <a:p>
-            <a:pPr algn="l" marL="171450" indent="-171450">
-              <a:lnSpc>
-                <a:spcPct val="115000"/>
-              </a:lnSpc>
-              <a:spcAft>
-                <a:spcPts val="400"/>
-              </a:spcAft>
-              <a:buClr>
-                <a:srgbClr val="08A6F6"/>
-              </a:buClr>
-              <a:buFont typeface="Arial"/>
-              <a:buChar char="•"/>
-            </a:pPr>
-            <a:r>
-              <a:rPr lang="zh-CN" altLang="en-US" sz="1100">
-                <a:solidFill>
-                  <a:srgbClr val="44546A"/>
-                </a:solidFill>
-                <a:latin typeface="微软雅黑"/>
-                <a:ea typeface="微软雅黑"/>
-                <a:cs typeface="微软雅黑"/>
-              </a:rPr>
-              <a:t>Cell Stem Cell 2025、npj Precision Oncology 2024 作者</a:t>
-            </a:r>
-          </a:p>
-        </p:txBody>
-      </p:sp>
-      <p:sp>
-        <p:nvSpPr>
-          <p:cNvPr id="305" name="照片 2"/>
+              <a:t>；密歇根大学安娜堡分校学士；亥姆霍兹研究生院奖学金</a:t>
+            </a:r>
+          </a:p>
+        </p:txBody>
+      </p:sp>
+      <p:sp>
+        <p:nvSpPr>
+          <p:cNvPr id="306" name="照片 2"/>
           <p:cNvSpPr/>
           <p:nvPr/>
         </p:nvSpPr>
         <p:spPr>
           <a:xfrm>
-            <a:off x="3960495" y="1097280"/>
-            <a:ext cx="1417320" cy="1417320"/>
+            <a:off x="4097655" y="1024128"/>
+            <a:ext cx="1143000" cy="1143000"/>
           </a:xfrm>
           <a:prstGeom prst="ellipse">
             <a:avLst/>
@@ -2077,7 +2148,7 @@
           <a:p>
             <a:pPr algn="ctr">
               <a:lnSpc>
-                <a:spcPct val="115000"/>
+                <a:spcPct val="112000"/>
               </a:lnSpc>
               <a:buNone/>
             </a:pPr>
@@ -2097,14 +2168,14 @@
       </p:sp>
       <p:sp>
         <p:nvSpPr>
-          <p:cNvPr id="306" name="姓名 2"/>
+          <p:cNvPr id="307" name="姓名 2"/>
           <p:cNvSpPr txBox="1"/>
           <p:nvPr/>
         </p:nvSpPr>
         <p:spPr>
           <a:xfrm>
-            <a:off x="3380994" y="2651760"/>
-            <a:ext cx="2576322" cy="347472"/>
+            <a:off x="3380994" y="2240280"/>
+            <a:ext cx="2576322" cy="329184"/>
           </a:xfrm>
           <a:prstGeom prst="rect">
             <a:avLst/>
@@ -2119,7 +2190,7 @@
           <a:p>
             <a:pPr algn="ctr">
               <a:lnSpc>
-                <a:spcPct val="115000"/>
+                <a:spcPct val="112000"/>
               </a:lnSpc>
               <a:buNone/>
             </a:pPr>
@@ -2139,14 +2210,14 @@
       </p:sp>
       <p:sp>
         <p:nvSpPr>
-          <p:cNvPr id="307" name="职位 2"/>
+          <p:cNvPr id="308" name="职位 2"/>
           <p:cNvSpPr txBox="1"/>
           <p:nvPr/>
         </p:nvSpPr>
         <p:spPr>
           <a:xfrm>
-            <a:off x="3380994" y="2999232"/>
-            <a:ext cx="2576322" cy="292608"/>
+            <a:off x="3380994" y="2560320"/>
+            <a:ext cx="2576322" cy="274320"/>
           </a:xfrm>
           <a:prstGeom prst="rect">
             <a:avLst/>
@@ -2161,7 +2232,7 @@
           <a:p>
             <a:pPr algn="ctr">
               <a:lnSpc>
-                <a:spcPct val="115000"/>
+                <a:spcPct val="112000"/>
               </a:lnSpc>
               <a:buNone/>
             </a:pPr>
@@ -2181,14 +2252,56 @@
       </p:sp>
       <p:sp>
         <p:nvSpPr>
-          <p:cNvPr id="308" name="经历 2"/>
+          <p:cNvPr id="309" name="亮点 2"/>
           <p:cNvSpPr txBox="1"/>
           <p:nvPr/>
         </p:nvSpPr>
         <p:spPr>
           <a:xfrm>
-            <a:off x="3472434" y="3474720"/>
-            <a:ext cx="2439162" cy="2788920"/>
+            <a:off x="3380994" y="2852928"/>
+            <a:ext cx="2576322" cy="256032"/>
+          </a:xfrm>
+          <a:prstGeom prst="rect">
+            <a:avLst/>
+          </a:prstGeom>
+          <a:noFill/>
+        </p:spPr>
+        <p:txBody>
+          <a:bodyPr wrap="square" lIns="0" tIns="0" rIns="0" bIns="0" anchor="ctr">
+            <a:noAutofit/>
+          </a:bodyPr>
+          <a:lstStyle/>
+          <a:p>
+            <a:pPr algn="ctr">
+              <a:lnSpc>
+                <a:spcPct val="112000"/>
+              </a:lnSpc>
+              <a:buNone/>
+            </a:pPr>
+            <a:r>
+              <a:rPr lang="zh-CN" altLang="en-US" sz="1050">
+                <a:solidFill>
+                  <a:srgbClr val="44546A"/>
+                </a:solidFill>
+                <a:latin typeface="微软雅黑"/>
+                <a:ea typeface="微软雅黑"/>
+                <a:cs typeface="微软雅黑"/>
+              </a:rPr>
+              <a:t>神经科学 × 脑类器官 × 产业转化</a:t>
+            </a:r>
+          </a:p>
+        </p:txBody>
+      </p:sp>
+      <p:sp>
+        <p:nvSpPr>
+          <p:cNvPr id="310" name="经历 2"/>
+          <p:cNvSpPr txBox="1"/>
+          <p:nvPr/>
+        </p:nvSpPr>
+        <p:spPr>
+          <a:xfrm>
+            <a:off x="3454146" y="3246120"/>
+            <a:ext cx="2484882" cy="3063240"/>
           </a:xfrm>
           <a:prstGeom prst="rect">
             <a:avLst/>
@@ -2203,10 +2316,10 @@
           <a:p>
             <a:pPr algn="l" marL="171450" indent="-171450">
               <a:lnSpc>
-                <a:spcPct val="115000"/>
+                <a:spcPct val="112000"/>
               </a:lnSpc>
               <a:spcAft>
-                <a:spcPts val="400"/>
+                <a:spcPts val="300"/>
               </a:spcAft>
               <a:buClr>
                 <a:srgbClr val="08A6F6"/>
@@ -2215,7 +2328,18 @@
               <a:buChar char="•"/>
             </a:pPr>
             <a:r>
-              <a:rPr lang="zh-CN" altLang="en-US" sz="1100">
+              <a:rPr lang="zh-CN" altLang="en-US" sz="1000" b="1">
+                <a:solidFill>
+                  <a:srgbClr val="061F32"/>
+                </a:solidFill>
+                <a:latin typeface="微软雅黑"/>
+                <a:ea typeface="微软雅黑"/>
+                <a:cs typeface="微软雅黑"/>
+              </a:rPr>
+              <a:t>霍英东杰出青年学者</a:t>
+            </a:r>
+            <a:r>
+              <a:rPr lang="zh-CN" altLang="en-US" sz="1000">
                 <a:solidFill>
                   <a:srgbClr val="44546A"/>
                 </a:solidFill>
@@ -2223,16 +2347,16 @@
                 <a:ea typeface="微软雅黑"/>
                 <a:cs typeface="微软雅黑"/>
               </a:rPr>
-              <a:t>DKFZ / 海德堡大学分子神经遗传学资深科学家</a:t>
+              <a:t>；中山大学香港高等研究所研究员</a:t>
             </a:r>
           </a:p>
           <a:p>
             <a:pPr algn="l" marL="171450" indent="-171450">
               <a:lnSpc>
-                <a:spcPct val="115000"/>
+                <a:spcPct val="112000"/>
               </a:lnSpc>
               <a:spcAft>
-                <a:spcPts val="400"/>
+                <a:spcPts val="300"/>
               </a:spcAft>
               <a:buClr>
                 <a:srgbClr val="08A6F6"/>
@@ -2241,7 +2365,18 @@
               <a:buChar char="•"/>
             </a:pPr>
             <a:r>
-              <a:rPr lang="zh-CN" altLang="en-US" sz="1100">
+              <a:rPr lang="zh-CN" altLang="en-US" sz="1000" b="1">
+                <a:solidFill>
+                  <a:srgbClr val="061F32"/>
+                </a:solidFill>
+                <a:latin typeface="微软雅黑"/>
+                <a:ea typeface="微软雅黑"/>
+                <a:cs typeface="微软雅黑"/>
+              </a:rPr>
+              <a:t>DKFZ 资深科学家、课题负责人</a:t>
+            </a:r>
+            <a:r>
+              <a:rPr lang="zh-CN" altLang="en-US" sz="1000">
                 <a:solidFill>
                   <a:srgbClr val="44546A"/>
                 </a:solidFill>
@@ -2249,16 +2384,16 @@
                 <a:ea typeface="微软雅黑"/>
                 <a:cs typeface="微软雅黑"/>
               </a:rPr>
-              <a:t>霍英东杰出青年学者</a:t>
+              <a:t>；海德堡大学医院开展患者来源肿瘤类器官指导的个体化胶质母细胞瘤治疗研究</a:t>
             </a:r>
           </a:p>
           <a:p>
             <a:pPr algn="l" marL="171450" indent="-171450">
               <a:lnSpc>
-                <a:spcPct val="115000"/>
+                <a:spcPct val="112000"/>
               </a:lnSpc>
               <a:spcAft>
-                <a:spcPts val="400"/>
+                <a:spcPts val="300"/>
               </a:spcAft>
               <a:buClr>
                 <a:srgbClr val="08A6F6"/>
@@ -2267,7 +2402,18 @@
               <a:buChar char="•"/>
             </a:pPr>
             <a:r>
-              <a:rPr lang="zh-CN" altLang="en-US" sz="1100">
+              <a:rPr lang="zh-CN" altLang="en-US" sz="1000" b="1">
+                <a:solidFill>
+                  <a:srgbClr val="061F32"/>
+                </a:solidFill>
+                <a:latin typeface="微软雅黑"/>
+                <a:ea typeface="微软雅黑"/>
+                <a:cs typeface="微软雅黑"/>
+              </a:rPr>
+              <a:t>第一作者成果 Science（修回中）、Cell（投稿中）</a:t>
+            </a:r>
+            <a:r>
+              <a:rPr lang="zh-CN" altLang="en-US" sz="1000">
                 <a:solidFill>
                   <a:srgbClr val="44546A"/>
                 </a:solidFill>
@@ -2275,16 +2421,16 @@
                 <a:ea typeface="微软雅黑"/>
                 <a:cs typeface="微软雅黑"/>
               </a:rPr>
-              <a:t>主持欧中重大科研项目</a:t>
+              <a:t>；Cell Stem Cell 2025 等 19 篇论文</a:t>
             </a:r>
           </a:p>
           <a:p>
             <a:pPr algn="l" marL="171450" indent="-171450">
               <a:lnSpc>
-                <a:spcPct val="115000"/>
+                <a:spcPct val="112000"/>
               </a:lnSpc>
               <a:spcAft>
-                <a:spcPts val="400"/>
+                <a:spcPts val="300"/>
               </a:spcAft>
               <a:buClr>
                 <a:srgbClr val="08A6F6"/>
@@ -2293,7 +2439,18 @@
               <a:buChar char="•"/>
             </a:pPr>
             <a:r>
-              <a:rPr lang="zh-CN" altLang="en-US" sz="1100">
+              <a:rPr lang="zh-CN" altLang="en-US" sz="1000" b="1">
+                <a:solidFill>
+                  <a:srgbClr val="061F32"/>
+                </a:solidFill>
+                <a:latin typeface="微软雅黑"/>
+                <a:ea typeface="微软雅黑"/>
+                <a:cs typeface="微软雅黑"/>
+              </a:rPr>
+              <a:t>参与 ERC、DFG、HFSP、NIH BRAIN Initiative</a:t>
+            </a:r>
+            <a:r>
+              <a:rPr lang="zh-CN" altLang="en-US" sz="1000">
                 <a:solidFill>
                   <a:srgbClr val="44546A"/>
                 </a:solidFill>
@@ -2301,16 +2458,16 @@
                 <a:ea typeface="微软雅黑"/>
                 <a:cs typeface="微软雅黑"/>
               </a:rPr>
-              <a:t>深耕神经调控与脑类器官方向，长期研究胶质母细胞瘤复发与耐药</a:t>
+              <a:t>及国家 973 / 863 等重大项目</a:t>
             </a:r>
           </a:p>
           <a:p>
             <a:pPr algn="l" marL="171450" indent="-171450">
               <a:lnSpc>
-                <a:spcPct val="115000"/>
+                <a:spcPct val="112000"/>
               </a:lnSpc>
               <a:spcAft>
-                <a:spcPts val="400"/>
+                <a:spcPts val="300"/>
               </a:spcAft>
               <a:buClr>
                 <a:srgbClr val="08A6F6"/>
@@ -2319,7 +2476,18 @@
               <a:buChar char="•"/>
             </a:pPr>
             <a:r>
-              <a:rPr lang="zh-CN" altLang="en-US" sz="1100">
+              <a:rPr lang="zh-CN" altLang="en-US" sz="1000" b="1">
+                <a:solidFill>
+                  <a:srgbClr val="061F32"/>
+                </a:solidFill>
+                <a:latin typeface="微软雅黑"/>
+                <a:ea typeface="微软雅黑"/>
+                <a:cs typeface="微软雅黑"/>
+              </a:rPr>
+              <a:t>Neusician 首席神经科学官</a:t>
+            </a:r>
+            <a:r>
+              <a:rPr lang="zh-CN" altLang="en-US" sz="1000">
                 <a:solidFill>
                   <a:srgbClr val="44546A"/>
                 </a:solidFill>
@@ -2327,21 +2495,21 @@
                 <a:ea typeface="微软雅黑"/>
                 <a:cs typeface="微软雅黑"/>
               </a:rPr>
-              <a:t>Cell Stem Cell 2025、npj Precision Oncology 2024 核心成员</a:t>
-            </a:r>
-          </a:p>
-        </p:txBody>
-      </p:sp>
-      <p:sp>
-        <p:nvSpPr>
-          <p:cNvPr id="309" name="照片 3"/>
+              <a:t>；慕尼黑大学 / 亥姆霍兹中心神经生物学博士</a:t>
+            </a:r>
+          </a:p>
+        </p:txBody>
+      </p:sp>
+      <p:sp>
+        <p:nvSpPr>
+          <p:cNvPr id="311" name="照片 3"/>
           <p:cNvSpPr/>
           <p:nvPr/>
         </p:nvSpPr>
         <p:spPr>
           <a:xfrm>
-            <a:off x="6811137" y="1097280"/>
-            <a:ext cx="1417320" cy="1417320"/>
+            <a:off x="6948297" y="1024128"/>
+            <a:ext cx="1143000" cy="1143000"/>
           </a:xfrm>
           <a:prstGeom prst="ellipse">
             <a:avLst/>
@@ -2361,7 +2529,7 @@
           <a:p>
             <a:pPr algn="ctr">
               <a:lnSpc>
-                <a:spcPct val="115000"/>
+                <a:spcPct val="112000"/>
               </a:lnSpc>
               <a:buNone/>
             </a:pPr>
@@ -2381,14 +2549,14 @@
       </p:sp>
       <p:sp>
         <p:nvSpPr>
-          <p:cNvPr id="310" name="姓名 3"/>
+          <p:cNvPr id="312" name="姓名 3"/>
           <p:cNvSpPr txBox="1"/>
           <p:nvPr/>
         </p:nvSpPr>
         <p:spPr>
           <a:xfrm>
-            <a:off x="6231636" y="2651760"/>
-            <a:ext cx="2576322" cy="347472"/>
+            <a:off x="6231636" y="2240280"/>
+            <a:ext cx="2576322" cy="329184"/>
           </a:xfrm>
           <a:prstGeom prst="rect">
             <a:avLst/>
@@ -2403,7 +2571,7 @@
           <a:p>
             <a:pPr algn="ctr">
               <a:lnSpc>
-                <a:spcPct val="115000"/>
+                <a:spcPct val="112000"/>
               </a:lnSpc>
               <a:buNone/>
             </a:pPr>
@@ -2423,14 +2591,14 @@
       </p:sp>
       <p:sp>
         <p:nvSpPr>
-          <p:cNvPr id="311" name="职位 3"/>
+          <p:cNvPr id="313" name="职位 3"/>
           <p:cNvSpPr txBox="1"/>
           <p:nvPr/>
         </p:nvSpPr>
         <p:spPr>
           <a:xfrm>
-            <a:off x="6231636" y="2999232"/>
-            <a:ext cx="2576322" cy="292608"/>
+            <a:off x="6231636" y="2560320"/>
+            <a:ext cx="2576322" cy="274320"/>
           </a:xfrm>
           <a:prstGeom prst="rect">
             <a:avLst/>
@@ -2445,7 +2613,7 @@
           <a:p>
             <a:pPr algn="ctr">
               <a:lnSpc>
-                <a:spcPct val="115000"/>
+                <a:spcPct val="112000"/>
               </a:lnSpc>
               <a:buNone/>
             </a:pPr>
@@ -2465,14 +2633,56 @@
       </p:sp>
       <p:sp>
         <p:nvSpPr>
-          <p:cNvPr id="312" name="经历 3"/>
+          <p:cNvPr id="314" name="亮点 3"/>
           <p:cNvSpPr txBox="1"/>
           <p:nvPr/>
         </p:nvSpPr>
         <p:spPr>
           <a:xfrm>
-            <a:off x="6323076" y="3474720"/>
-            <a:ext cx="2439162" cy="2788920"/>
+            <a:off x="6231636" y="2852928"/>
+            <a:ext cx="2576322" cy="256032"/>
+          </a:xfrm>
+          <a:prstGeom prst="rect">
+            <a:avLst/>
+          </a:prstGeom>
+          <a:noFill/>
+        </p:spPr>
+        <p:txBody>
+          <a:bodyPr wrap="square" lIns="0" tIns="0" rIns="0" bIns="0" anchor="ctr">
+            <a:noAutofit/>
+          </a:bodyPr>
+          <a:lstStyle/>
+          <a:p>
+            <a:pPr algn="ctr">
+              <a:lnSpc>
+                <a:spcPct val="112000"/>
+              </a:lnSpc>
+              <a:buNone/>
+            </a:pPr>
+            <a:r>
+              <a:rPr lang="zh-CN" altLang="en-US" sz="1050">
+                <a:solidFill>
+                  <a:srgbClr val="44546A"/>
+                </a:solidFill>
+                <a:latin typeface="微软雅黑"/>
+                <a:ea typeface="微软雅黑"/>
+                <a:cs typeface="微软雅黑"/>
+              </a:rPr>
+              <a:t>生物信息 × 机器学习预测建模</a:t>
+            </a:r>
+          </a:p>
+        </p:txBody>
+      </p:sp>
+      <p:sp>
+        <p:nvSpPr>
+          <p:cNvPr id="315" name="经历 3"/>
+          <p:cNvSpPr txBox="1"/>
+          <p:nvPr/>
+        </p:nvSpPr>
+        <p:spPr>
+          <a:xfrm>
+            <a:off x="6304788" y="3246120"/>
+            <a:ext cx="2484882" cy="3063240"/>
           </a:xfrm>
           <a:prstGeom prst="rect">
             <a:avLst/>
@@ -2487,10 +2697,10 @@
           <a:p>
             <a:pPr algn="l" marL="171450" indent="-171450">
               <a:lnSpc>
-                <a:spcPct val="115000"/>
+                <a:spcPct val="112000"/>
               </a:lnSpc>
               <a:spcAft>
-                <a:spcPts val="400"/>
+                <a:spcPts val="300"/>
               </a:spcAft>
               <a:buClr>
                 <a:srgbClr val="08A6F6"/>
@@ -2499,7 +2709,18 @@
               <a:buChar char="•"/>
             </a:pPr>
             <a:r>
-              <a:rPr lang="zh-CN" altLang="en-US" sz="1100">
+              <a:rPr lang="zh-CN" altLang="en-US" sz="1000" b="1">
+                <a:solidFill>
+                  <a:srgbClr val="061F32"/>
+                </a:solidFill>
+                <a:latin typeface="微软雅黑"/>
+                <a:ea typeface="微软雅黑"/>
+                <a:cs typeface="微软雅黑"/>
+              </a:rPr>
+              <a:t>慕尼黑工业大学 / 慕尼黑亥姆霍兹中心生物信息学博士</a:t>
+            </a:r>
+            <a:r>
+              <a:rPr lang="zh-CN" altLang="en-US" sz="1000">
                 <a:solidFill>
                   <a:srgbClr val="44546A"/>
                 </a:solidFill>
@@ -2507,16 +2728,16 @@
                 <a:ea typeface="微软雅黑"/>
                 <a:cs typeface="微软雅黑"/>
               </a:rPr>
-              <a:t>慕尼黑大学博士</a:t>
+              <a:t>；厦门大学硕士</a:t>
             </a:r>
           </a:p>
           <a:p>
             <a:pPr algn="l" marL="171450" indent="-171450">
               <a:lnSpc>
-                <a:spcPct val="115000"/>
+                <a:spcPct val="112000"/>
               </a:lnSpc>
               <a:spcAft>
-                <a:spcPts val="400"/>
+                <a:spcPts val="300"/>
               </a:spcAft>
               <a:buClr>
                 <a:srgbClr val="08A6F6"/>
@@ -2525,7 +2746,18 @@
               <a:buChar char="•"/>
             </a:pPr>
             <a:r>
-              <a:rPr lang="zh-CN" altLang="en-US" sz="1100">
+              <a:rPr lang="zh-CN" altLang="en-US" sz="1000" b="1">
+                <a:solidFill>
+                  <a:srgbClr val="061F32"/>
+                </a:solidFill>
+                <a:latin typeface="微软雅黑"/>
+                <a:ea typeface="微软雅黑"/>
+                <a:cs typeface="微软雅黑"/>
+              </a:rPr>
+              <a:t>约 10 年生物信息与多组学分析经验</a:t>
+            </a:r>
+            <a:r>
+              <a:rPr lang="zh-CN" altLang="en-US" sz="1000">
                 <a:solidFill>
                   <a:srgbClr val="44546A"/>
                 </a:solidFill>
@@ -2533,16 +2765,16 @@
                 <a:ea typeface="微软雅黑"/>
                 <a:cs typeface="微软雅黑"/>
               </a:rPr>
-              <a:t>曾任职哈佛医学院</a:t>
+              <a:t>；曾任职哈佛医学院，负责临床试验数据与多组学预测建模</a:t>
             </a:r>
           </a:p>
           <a:p>
             <a:pPr algn="l" marL="171450" indent="-171450">
               <a:lnSpc>
-                <a:spcPct val="115000"/>
+                <a:spcPct val="112000"/>
               </a:lnSpc>
               <a:spcAft>
-                <a:spcPts val="400"/>
+                <a:spcPts val="300"/>
               </a:spcAft>
               <a:buClr>
                 <a:srgbClr val="08A6F6"/>
@@ -2551,7 +2783,18 @@
               <a:buChar char="•"/>
             </a:pPr>
             <a:r>
-              <a:rPr lang="zh-CN" altLang="en-US" sz="1100">
+              <a:rPr lang="zh-CN" altLang="en-US" sz="1000" b="1">
+                <a:solidFill>
+                  <a:srgbClr val="061F32"/>
+                </a:solidFill>
+                <a:latin typeface="微软雅黑"/>
+                <a:ea typeface="微软雅黑"/>
+                <a:cs typeface="微软雅黑"/>
+              </a:rPr>
+              <a:t>预测模型 AUC &gt; 0.95</a:t>
+            </a:r>
+            <a:r>
+              <a:rPr lang="zh-CN" altLang="en-US" sz="1000">
                 <a:solidFill>
                   <a:srgbClr val="44546A"/>
                 </a:solidFill>
@@ -2559,16 +2802,16 @@
                 <a:ea typeface="微软雅黑"/>
                 <a:cs typeface="微软雅黑"/>
               </a:rPr>
-              <a:t>近 10 年生物信息与多组学数据分析经验</a:t>
+              <a:t>（高维数据分类）；临床多组学预测 AUC &gt; 0.80</a:t>
             </a:r>
           </a:p>
           <a:p>
             <a:pPr algn="l" marL="171450" indent="-171450">
               <a:lnSpc>
-                <a:spcPct val="115000"/>
+                <a:spcPct val="112000"/>
               </a:lnSpc>
               <a:spcAft>
-                <a:spcPts val="400"/>
+                <a:spcPts val="300"/>
               </a:spcAft>
               <a:buClr>
                 <a:srgbClr val="08A6F6"/>
@@ -2577,7 +2820,18 @@
               <a:buChar char="•"/>
             </a:pPr>
             <a:r>
-              <a:rPr lang="zh-CN" altLang="en-US" sz="1100">
+              <a:rPr lang="zh-CN" altLang="en-US" sz="1000" b="1">
+                <a:solidFill>
+                  <a:srgbClr val="061F32"/>
+                </a:solidFill>
+                <a:latin typeface="微软雅黑"/>
+                <a:ea typeface="微软雅黑"/>
+                <a:cs typeface="微软雅黑"/>
+              </a:rPr>
+              <a:t>多模态 + 纵向数据整合</a:t>
+            </a:r>
+            <a:r>
+              <a:rPr lang="zh-CN" altLang="en-US" sz="1000">
                 <a:solidFill>
                   <a:srgbClr val="44546A"/>
                 </a:solidFill>
@@ -2585,16 +2839,16 @@
                 <a:ea typeface="微软雅黑"/>
                 <a:cs typeface="微软雅黑"/>
               </a:rPr>
-              <a:t>精通大规模计算与机器学习预测建模</a:t>
+              <a:t>：测序、转录、代谢、表型与临床元数据</a:t>
             </a:r>
           </a:p>
           <a:p>
             <a:pPr algn="l" marL="171450" indent="-171450">
               <a:lnSpc>
-                <a:spcPct val="115000"/>
+                <a:spcPct val="112000"/>
               </a:lnSpc>
               <a:spcAft>
-                <a:spcPts val="400"/>
+                <a:spcPts val="300"/>
               </a:spcAft>
               <a:buClr>
                 <a:srgbClr val="08A6F6"/>
@@ -2603,7 +2857,18 @@
               <a:buChar char="•"/>
             </a:pPr>
             <a:r>
-              <a:rPr lang="zh-CN" altLang="en-US" sz="1100">
+              <a:rPr lang="zh-CN" altLang="en-US" sz="1000" b="1">
+                <a:solidFill>
+                  <a:srgbClr val="061F32"/>
+                </a:solidFill>
+                <a:latin typeface="微软雅黑"/>
+                <a:ea typeface="微软雅黑"/>
+                <a:cs typeface="微软雅黑"/>
+              </a:rPr>
+              <a:t>HPC / SLURM 规模化分析流程</a:t>
+            </a:r>
+            <a:r>
+              <a:rPr lang="zh-CN" altLang="en-US" sz="1000">
                 <a:solidFill>
                   <a:srgbClr val="44546A"/>
                 </a:solidFill>
@@ -2611,21 +2876,21 @@
                 <a:ea typeface="微软雅黑"/>
                 <a:cs typeface="微软雅黑"/>
               </a:rPr>
-              <a:t>擅长搭建端到端可复用分析流程，支撑临床与生物医药项目的数据挖掘与决策输出</a:t>
-            </a:r>
-          </a:p>
-        </p:txBody>
-      </p:sp>
-      <p:sp>
-        <p:nvSpPr>
-          <p:cNvPr id="313" name="照片 4"/>
+              <a:t>，单批覆盖数百至数千样本</a:t>
+            </a:r>
+          </a:p>
+        </p:txBody>
+      </p:sp>
+      <p:sp>
+        <p:nvSpPr>
+          <p:cNvPr id="316" name="照片 4"/>
           <p:cNvSpPr/>
           <p:nvPr/>
         </p:nvSpPr>
         <p:spPr>
           <a:xfrm>
-            <a:off x="9661779" y="1097280"/>
-            <a:ext cx="1417320" cy="1417320"/>
+            <a:off x="9798939" y="1024128"/>
+            <a:ext cx="1143000" cy="1143000"/>
           </a:xfrm>
           <a:prstGeom prst="ellipse">
             <a:avLst/>
@@ -2645,7 +2910,7 @@
           <a:p>
             <a:pPr algn="ctr">
               <a:lnSpc>
-                <a:spcPct val="115000"/>
+                <a:spcPct val="112000"/>
               </a:lnSpc>
               <a:buNone/>
             </a:pPr>
@@ -2665,14 +2930,14 @@
       </p:sp>
       <p:sp>
         <p:nvSpPr>
-          <p:cNvPr id="314" name="姓名 4"/>
+          <p:cNvPr id="317" name="姓名 4"/>
           <p:cNvSpPr txBox="1"/>
           <p:nvPr/>
         </p:nvSpPr>
         <p:spPr>
           <a:xfrm>
-            <a:off x="9082278" y="2651760"/>
-            <a:ext cx="2576322" cy="347472"/>
+            <a:off x="9082278" y="2240280"/>
+            <a:ext cx="2576322" cy="329184"/>
           </a:xfrm>
           <a:prstGeom prst="rect">
             <a:avLst/>
@@ -2687,7 +2952,7 @@
           <a:p>
             <a:pPr algn="ctr">
               <a:lnSpc>
-                <a:spcPct val="115000"/>
+                <a:spcPct val="112000"/>
               </a:lnSpc>
               <a:buNone/>
             </a:pPr>
@@ -2707,14 +2972,14 @@
       </p:sp>
       <p:sp>
         <p:nvSpPr>
-          <p:cNvPr id="315" name="职位 4"/>
+          <p:cNvPr id="318" name="职位 4"/>
           <p:cNvSpPr txBox="1"/>
           <p:nvPr/>
         </p:nvSpPr>
         <p:spPr>
           <a:xfrm>
-            <a:off x="9082278" y="2999232"/>
-            <a:ext cx="2576322" cy="292608"/>
+            <a:off x="9082278" y="2560320"/>
+            <a:ext cx="2576322" cy="274320"/>
           </a:xfrm>
           <a:prstGeom prst="rect">
             <a:avLst/>
@@ -2729,7 +2994,7 @@
           <a:p>
             <a:pPr algn="ctr">
               <a:lnSpc>
-                <a:spcPct val="115000"/>
+                <a:spcPct val="112000"/>
               </a:lnSpc>
               <a:buNone/>
             </a:pPr>
@@ -2749,14 +3014,56 @@
       </p:sp>
       <p:sp>
         <p:nvSpPr>
-          <p:cNvPr id="316" name="经历 4"/>
+          <p:cNvPr id="319" name="亮点 4"/>
           <p:cNvSpPr txBox="1"/>
           <p:nvPr/>
         </p:nvSpPr>
         <p:spPr>
           <a:xfrm>
-            <a:off x="9173718" y="3474720"/>
-            <a:ext cx="2439162" cy="2788920"/>
+            <a:off x="9082278" y="2852928"/>
+            <a:ext cx="2576322" cy="256032"/>
+          </a:xfrm>
+          <a:prstGeom prst="rect">
+            <a:avLst/>
+          </a:prstGeom>
+          <a:noFill/>
+        </p:spPr>
+        <p:txBody>
+          <a:bodyPr wrap="square" lIns="0" tIns="0" rIns="0" bIns="0" anchor="ctr">
+            <a:noAutofit/>
+          </a:bodyPr>
+          <a:lstStyle/>
+          <a:p>
+            <a:pPr algn="ctr">
+              <a:lnSpc>
+                <a:spcPct val="112000"/>
+              </a:lnSpc>
+              <a:buNone/>
+            </a:pPr>
+            <a:r>
+              <a:rPr lang="zh-CN" altLang="en-US" sz="1050">
+                <a:solidFill>
+                  <a:srgbClr val="44546A"/>
+                </a:solidFill>
+                <a:latin typeface="微软雅黑"/>
+                <a:ea typeface="微软雅黑"/>
+                <a:cs typeface="微软雅黑"/>
+              </a:rPr>
+              <a:t>跨境金融风控 × 科创运营</a:t>
+            </a:r>
+          </a:p>
+        </p:txBody>
+      </p:sp>
+      <p:sp>
+        <p:nvSpPr>
+          <p:cNvPr id="320" name="经历 4"/>
+          <p:cNvSpPr txBox="1"/>
+          <p:nvPr/>
+        </p:nvSpPr>
+        <p:spPr>
+          <a:xfrm>
+            <a:off x="9155430" y="3246120"/>
+            <a:ext cx="2484882" cy="3063240"/>
           </a:xfrm>
           <a:prstGeom prst="rect">
             <a:avLst/>
@@ -2771,10 +3078,10 @@
           <a:p>
             <a:pPr algn="l" marL="171450" indent="-171450">
               <a:lnSpc>
-                <a:spcPct val="115000"/>
+                <a:spcPct val="112000"/>
               </a:lnSpc>
               <a:spcAft>
-                <a:spcPts val="400"/>
+                <a:spcPts val="300"/>
               </a:spcAft>
               <a:buClr>
                 <a:srgbClr val="08A6F6"/>
@@ -2783,7 +3090,18 @@
               <a:buChar char="•"/>
             </a:pPr>
             <a:r>
-              <a:rPr lang="zh-CN" altLang="en-US" sz="1100">
+              <a:rPr lang="zh-CN" altLang="en-US" sz="1000" b="1">
+                <a:solidFill>
+                  <a:srgbClr val="061F32"/>
+                </a:solidFill>
+                <a:latin typeface="微软雅黑"/>
+                <a:ea typeface="微软雅黑"/>
+                <a:cs typeface="微软雅黑"/>
+              </a:rPr>
+              <a:t>德国商业银行（Commerzbank）高级合规官</a:t>
+            </a:r>
+            <a:r>
+              <a:rPr lang="zh-CN" altLang="en-US" sz="1000">
                 <a:solidFill>
                   <a:srgbClr val="44546A"/>
                 </a:solidFill>
@@ -2791,16 +3109,16 @@
                 <a:ea typeface="微软雅黑"/>
                 <a:cs typeface="微软雅黑"/>
               </a:rPr>
-              <a:t>海德堡大学经济学硕士</a:t>
+              <a:t>：统筹集团全球分支风控合规，向董事会提交风险研判</a:t>
             </a:r>
           </a:p>
           <a:p>
             <a:pPr algn="l" marL="171450" indent="-171450">
               <a:lnSpc>
-                <a:spcPct val="115000"/>
+                <a:spcPct val="112000"/>
               </a:lnSpc>
               <a:spcAft>
-                <a:spcPts val="400"/>
+                <a:spcPts val="300"/>
               </a:spcAft>
               <a:buClr>
                 <a:srgbClr val="08A6F6"/>
@@ -2809,7 +3127,18 @@
               <a:buChar char="•"/>
             </a:pPr>
             <a:r>
-              <a:rPr lang="zh-CN" altLang="en-US" sz="1100">
+              <a:rPr lang="zh-CN" altLang="en-US" sz="1000" b="1">
+                <a:solidFill>
+                  <a:srgbClr val="061F32"/>
+                </a:solidFill>
+                <a:latin typeface="微软雅黑"/>
+                <a:ea typeface="微软雅黑"/>
+                <a:cs typeface="微软雅黑"/>
+              </a:rPr>
+              <a:t>曾任 Sopra Steria 合规官</a:t>
+            </a:r>
+            <a:r>
+              <a:rPr lang="zh-CN" altLang="en-US" sz="1000">
                 <a:solidFill>
                   <a:srgbClr val="44546A"/>
                 </a:solidFill>
@@ -2817,16 +3146,16 @@
                 <a:ea typeface="微软雅黑"/>
                 <a:cs typeface="微软雅黑"/>
               </a:rPr>
-              <a:t>浙江大学管理学学士（竺可桢学院创业与创新管理强化班）</a:t>
+              <a:t>、中国银行法兰克福分行反洗钱分析师</a:t>
             </a:r>
           </a:p>
           <a:p>
             <a:pPr algn="l" marL="171450" indent="-171450">
               <a:lnSpc>
-                <a:spcPct val="115000"/>
+                <a:spcPct val="112000"/>
               </a:lnSpc>
               <a:spcAft>
-                <a:spcPts val="400"/>
+                <a:spcPts val="300"/>
               </a:spcAft>
               <a:buClr>
                 <a:srgbClr val="08A6F6"/>
@@ -2835,7 +3164,18 @@
               <a:buChar char="•"/>
             </a:pPr>
             <a:r>
-              <a:rPr lang="zh-CN" altLang="en-US" sz="1100">
+              <a:rPr lang="zh-CN" altLang="en-US" sz="1000" b="1">
+                <a:solidFill>
+                  <a:srgbClr val="061F32"/>
+                </a:solidFill>
+                <a:latin typeface="微软雅黑"/>
+                <a:ea typeface="微软雅黑"/>
+                <a:cs typeface="微软雅黑"/>
+              </a:rPr>
+              <a:t>歌德商学院高管教育中心高级项目经理</a:t>
+            </a:r>
+            <a:r>
+              <a:rPr lang="zh-CN" altLang="en-US" sz="1000">
                 <a:solidFill>
                   <a:srgbClr val="44546A"/>
                 </a:solidFill>
@@ -2843,16 +3183,16 @@
                 <a:ea typeface="微软雅黑"/>
                 <a:cs typeface="微软雅黑"/>
               </a:rPr>
-              <a:t>FRM 持证人</a:t>
+              <a:t>：搭建中德企业家与科创创始人交流平台</a:t>
             </a:r>
           </a:p>
           <a:p>
             <a:pPr algn="l" marL="171450" indent="-171450">
               <a:lnSpc>
-                <a:spcPct val="115000"/>
+                <a:spcPct val="112000"/>
               </a:lnSpc>
               <a:spcAft>
-                <a:spcPts val="400"/>
+                <a:spcPts val="300"/>
               </a:spcAft>
               <a:buClr>
                 <a:srgbClr val="08A6F6"/>
@@ -2861,7 +3201,18 @@
               <a:buChar char="•"/>
             </a:pPr>
             <a:r>
-              <a:rPr lang="zh-CN" altLang="en-US" sz="1100">
+              <a:rPr lang="zh-CN" altLang="en-US" sz="1000" b="1">
+                <a:solidFill>
+                  <a:srgbClr val="061F32"/>
+                </a:solidFill>
+                <a:latin typeface="微软雅黑"/>
+                <a:ea typeface="微软雅黑"/>
+                <a:cs typeface="微软雅黑"/>
+              </a:rPr>
+              <a:t>FRM、ESG Investing 认证</a:t>
+            </a:r>
+            <a:r>
+              <a:rPr lang="zh-CN" altLang="en-US" sz="1000">
                 <a:solidFill>
                   <a:srgbClr val="44546A"/>
                 </a:solidFill>
@@ -2869,16 +3220,16 @@
                 <a:ea typeface="微软雅黑"/>
                 <a:cs typeface="微软雅黑"/>
               </a:rPr>
-              <a:t>多年国际金融机构风控合规与跨境尽调经验</a:t>
+              <a:t>；CFA 一级；精通英语、德语</a:t>
             </a:r>
           </a:p>
           <a:p>
             <a:pPr algn="l" marL="171450" indent="-171450">
               <a:lnSpc>
-                <a:spcPct val="115000"/>
+                <a:spcPct val="112000"/>
               </a:lnSpc>
               <a:spcAft>
-                <a:spcPts val="400"/>
+                <a:spcPts val="300"/>
               </a:spcAft>
               <a:buClr>
                 <a:srgbClr val="08A6F6"/>
@@ -2887,7 +3238,18 @@
               <a:buChar char="•"/>
             </a:pPr>
             <a:r>
-              <a:rPr lang="zh-CN" altLang="en-US" sz="1100">
+              <a:rPr lang="zh-CN" altLang="en-US" sz="1000" b="1">
+                <a:solidFill>
+                  <a:srgbClr val="061F32"/>
+                </a:solidFill>
+                <a:latin typeface="微软雅黑"/>
+                <a:ea typeface="微软雅黑"/>
+                <a:cs typeface="微软雅黑"/>
+              </a:rPr>
+              <a:t>海德堡大学经济学硕士</a:t>
+            </a:r>
+            <a:r>
+              <a:rPr lang="zh-CN" altLang="en-US" sz="1000">
                 <a:solidFill>
                   <a:srgbClr val="44546A"/>
                 </a:solidFill>
@@ -2895,7 +3257,7 @@
                 <a:ea typeface="微软雅黑"/>
                 <a:cs typeface="微软雅黑"/>
               </a:rPr>
-              <a:t>精通跨境财务统筹、合规体系搭建与硬科技项目运营</a:t>
+              <a:t>；浙江大学管理学学士（竺可桢学院创新与创业管理强化班）</a:t>
             </a:r>
           </a:p>
         </p:txBody>

</xml_diff>

<commit_message>
Team slide: condense experience to keyword bullets, larger font
Co-Authored-By: Claude Opus 5.5 <noreply@anthropic.com>
Claude-Session: https://claude.ai/code/session_01NTagjVHGZdXLvG9VCNzDRT
</commit_message>
<xml_diff>
--- a/slides/Vitoma_BP_part1_team.pptx
+++ b/slides/Vitoma_BP_part1_team.pptx
@@ -1933,12 +1933,12 @@
           </a:bodyPr>
           <a:lstStyle/>
           <a:p>
-            <a:pPr algn="l" marL="171450" indent="-171450">
-              <a:lnSpc>
-                <a:spcPct val="112000"/>
+            <a:pPr marL="190500" indent="-190500">
+              <a:lnSpc>
+                <a:spcPct val="110000"/>
               </a:lnSpc>
               <a:spcAft>
-                <a:spcPts val="300"/>
+                <a:spcPts val="1000"/>
               </a:spcAft>
               <a:buClr>
                 <a:srgbClr val="08A6F6"/>
@@ -1947,7 +1947,7 @@
               <a:buChar char="•"/>
             </a:pPr>
             <a:r>
-              <a:rPr lang="zh-CN" altLang="en-US" sz="1000" b="1">
+              <a:rPr lang="zh-CN" altLang="en-US" sz="1400">
                 <a:solidFill>
                   <a:srgbClr val="061F32"/>
                 </a:solidFill>
@@ -1955,27 +1955,16 @@
                 <a:ea typeface="微软雅黑"/>
                 <a:cs typeface="微软雅黑"/>
               </a:rPr>
-              <a:t>Verqura 实验室管理系统创始人</a:t>
-            </a:r>
-            <a:r>
-              <a:rPr lang="zh-CN" altLang="en-US" sz="1000">
-                <a:solidFill>
-                  <a:srgbClr val="44546A"/>
-                </a:solidFill>
-                <a:latin typeface="微软雅黑"/>
-                <a:ea typeface="微软雅黑"/>
-                <a:cs typeface="微软雅黑"/>
-              </a:rPr>
-              <a:t>：打通样本、实验与数据管理</a:t>
-            </a:r>
-          </a:p>
-          <a:p>
-            <a:pPr algn="l" marL="171450" indent="-171450">
-              <a:lnSpc>
-                <a:spcPct val="112000"/>
+              <a:t>Verqura 实验系统创始人</a:t>
+            </a:r>
+          </a:p>
+          <a:p>
+            <a:pPr marL="190500" indent="-190500">
+              <a:lnSpc>
+                <a:spcPct val="110000"/>
               </a:lnSpc>
               <a:spcAft>
-                <a:spcPts val="300"/>
+                <a:spcPts val="1000"/>
               </a:spcAft>
               <a:buClr>
                 <a:srgbClr val="08A6F6"/>
@@ -1984,7 +1973,7 @@
               <a:buChar char="•"/>
             </a:pPr>
             <a:r>
-              <a:rPr lang="zh-CN" altLang="en-US" sz="1000" b="1">
+              <a:rPr lang="zh-CN" altLang="en-US" sz="1400">
                 <a:solidFill>
                   <a:srgbClr val="061F32"/>
                 </a:solidFill>
@@ -1992,27 +1981,16 @@
                 <a:ea typeface="微软雅黑"/>
                 <a:cs typeface="微软雅黑"/>
               </a:rPr>
-              <a:t>Cell Stem Cell 2025、npj Precision Oncology 2024 作者</a:t>
-            </a:r>
-            <a:r>
-              <a:rPr lang="zh-CN" altLang="en-US" sz="1000">
-                <a:solidFill>
-                  <a:srgbClr val="44546A"/>
-                </a:solidFill>
-                <a:latin typeface="微软雅黑"/>
-                <a:ea typeface="微软雅黑"/>
-                <a:cs typeface="微软雅黑"/>
-              </a:rPr>
-              <a:t>（类器官预测患者治疗响应）</a:t>
-            </a:r>
-          </a:p>
-          <a:p>
-            <a:pPr algn="l" marL="171450" indent="-171450">
-              <a:lnSpc>
-                <a:spcPct val="112000"/>
+              <a:t>Cell Stem Cell 2025 作者</a:t>
+            </a:r>
+          </a:p>
+          <a:p>
+            <a:pPr marL="190500" indent="-190500">
+              <a:lnSpc>
+                <a:spcPct val="110000"/>
               </a:lnSpc>
               <a:spcAft>
-                <a:spcPts val="300"/>
+                <a:spcPts val="1000"/>
               </a:spcAft>
               <a:buClr>
                 <a:srgbClr val="08A6F6"/>
@@ -2021,7 +1999,7 @@
               <a:buChar char="•"/>
             </a:pPr>
             <a:r>
-              <a:rPr lang="zh-CN" altLang="en-US" sz="1000" b="1">
+              <a:rPr lang="zh-CN" altLang="en-US" sz="1400">
                 <a:solidFill>
                   <a:srgbClr val="061F32"/>
                 </a:solidFill>
@@ -2029,27 +2007,16 @@
                 <a:ea typeface="微软雅黑"/>
                 <a:cs typeface="微软雅黑"/>
               </a:rPr>
-              <a:t>精通 iPSC 脑类器官构建</a:t>
-            </a:r>
-            <a:r>
-              <a:rPr lang="zh-CN" altLang="en-US" sz="1000">
-                <a:solidFill>
-                  <a:srgbClr val="44546A"/>
-                </a:solidFill>
-                <a:latin typeface="微软雅黑"/>
-                <a:ea typeface="微软雅黑"/>
-                <a:cs typeface="微软雅黑"/>
-              </a:rPr>
-              <a:t>，引进 Pașca 团队分化方案；CRISPR 基因组编辑</a:t>
-            </a:r>
-          </a:p>
-          <a:p>
-            <a:pPr algn="l" marL="171450" indent="-171450">
-              <a:lnSpc>
-                <a:spcPct val="112000"/>
+              <a:t>iPSC 脑类器官｜CRISPR</a:t>
+            </a:r>
+          </a:p>
+          <a:p>
+            <a:pPr marL="190500" indent="-190500">
+              <a:lnSpc>
+                <a:spcPct val="110000"/>
               </a:lnSpc>
               <a:spcAft>
-                <a:spcPts val="300"/>
+                <a:spcPts val="1000"/>
               </a:spcAft>
               <a:buClr>
                 <a:srgbClr val="08A6F6"/>
@@ -2058,7 +2025,7 @@
               <a:buChar char="•"/>
             </a:pPr>
             <a:r>
-              <a:rPr lang="zh-CN" altLang="en-US" sz="1000" b="1">
+              <a:rPr lang="zh-CN" altLang="en-US" sz="1400">
                 <a:solidFill>
                   <a:srgbClr val="061F32"/>
                 </a:solidFill>
@@ -2066,27 +2033,16 @@
                 <a:ea typeface="微软雅黑"/>
                 <a:cs typeface="微软雅黑"/>
               </a:rPr>
-              <a:t>单细胞 RNA / ATAC 测序分析</a:t>
-            </a:r>
-            <a:r>
-              <a:rPr lang="zh-CN" altLang="en-US" sz="1000">
-                <a:solidFill>
-                  <a:srgbClr val="44546A"/>
-                </a:solidFill>
-                <a:latin typeface="微软雅黑"/>
-                <a:ea typeface="微软雅黑"/>
-                <a:cs typeface="微软雅黑"/>
-              </a:rPr>
-              <a:t>；训练 YOLO / Cellpose 图像 AI 模型</a:t>
-            </a:r>
-          </a:p>
-          <a:p>
-            <a:pPr algn="l" marL="171450" indent="-171450">
-              <a:lnSpc>
-                <a:spcPct val="112000"/>
+              <a:t>单细胞组学｜图像 AI</a:t>
+            </a:r>
+          </a:p>
+          <a:p>
+            <a:pPr marL="190500" indent="-190500">
+              <a:lnSpc>
+                <a:spcPct val="110000"/>
               </a:lnSpc>
               <a:spcAft>
-                <a:spcPts val="300"/>
+                <a:spcPts val="1000"/>
               </a:spcAft>
               <a:buClr>
                 <a:srgbClr val="08A6F6"/>
@@ -2095,7 +2051,7 @@
               <a:buChar char="•"/>
             </a:pPr>
             <a:r>
-              <a:rPr lang="zh-CN" altLang="en-US" sz="1000" b="1">
+              <a:rPr lang="zh-CN" altLang="en-US" sz="1400">
                 <a:solidFill>
                   <a:srgbClr val="061F32"/>
                 </a:solidFill>
@@ -2103,18 +2059,7 @@
                 <a:ea typeface="微软雅黑"/>
                 <a:cs typeface="微软雅黑"/>
               </a:rPr>
-              <a:t>海德堡大学 / DKFZ 发育生物学博士</a:t>
-            </a:r>
-            <a:r>
-              <a:rPr lang="zh-CN" altLang="en-US" sz="1000">
-                <a:solidFill>
-                  <a:srgbClr val="44546A"/>
-                </a:solidFill>
-                <a:latin typeface="微软雅黑"/>
-                <a:ea typeface="微软雅黑"/>
-                <a:cs typeface="微软雅黑"/>
-              </a:rPr>
-              <a:t>；密歇根大学安娜堡分校学士；亥姆霍兹研究生院奖学金</a:t>
+              <a:t>海德堡大学 / DKFZ 博士</a:t>
             </a:r>
           </a:p>
         </p:txBody>
@@ -2314,12 +2259,12 @@
           </a:bodyPr>
           <a:lstStyle/>
           <a:p>
-            <a:pPr algn="l" marL="171450" indent="-171450">
-              <a:lnSpc>
-                <a:spcPct val="112000"/>
+            <a:pPr marL="190500" indent="-190500">
+              <a:lnSpc>
+                <a:spcPct val="110000"/>
               </a:lnSpc>
               <a:spcAft>
-                <a:spcPts val="300"/>
+                <a:spcPts val="1000"/>
               </a:spcAft>
               <a:buClr>
                 <a:srgbClr val="08A6F6"/>
@@ -2328,7 +2273,7 @@
               <a:buChar char="•"/>
             </a:pPr>
             <a:r>
-              <a:rPr lang="zh-CN" altLang="en-US" sz="1000" b="1">
+              <a:rPr lang="zh-CN" altLang="en-US" sz="1400">
                 <a:solidFill>
                   <a:srgbClr val="061F32"/>
                 </a:solidFill>
@@ -2338,25 +2283,14 @@
               </a:rPr>
               <a:t>霍英东杰出青年学者</a:t>
             </a:r>
-            <a:r>
-              <a:rPr lang="zh-CN" altLang="en-US" sz="1000">
-                <a:solidFill>
-                  <a:srgbClr val="44546A"/>
-                </a:solidFill>
-                <a:latin typeface="微软雅黑"/>
-                <a:ea typeface="微软雅黑"/>
-                <a:cs typeface="微软雅黑"/>
-              </a:rPr>
-              <a:t>；中山大学香港高等研究所研究员</a:t>
-            </a:r>
-          </a:p>
-          <a:p>
-            <a:pPr algn="l" marL="171450" indent="-171450">
-              <a:lnSpc>
-                <a:spcPct val="112000"/>
+          </a:p>
+          <a:p>
+            <a:pPr marL="190500" indent="-190500">
+              <a:lnSpc>
+                <a:spcPct val="110000"/>
               </a:lnSpc>
               <a:spcAft>
-                <a:spcPts val="300"/>
+                <a:spcPts val="1000"/>
               </a:spcAft>
               <a:buClr>
                 <a:srgbClr val="08A6F6"/>
@@ -2365,7 +2299,7 @@
               <a:buChar char="•"/>
             </a:pPr>
             <a:r>
-              <a:rPr lang="zh-CN" altLang="en-US" sz="1000" b="1">
+              <a:rPr lang="zh-CN" altLang="en-US" sz="1400">
                 <a:solidFill>
                   <a:srgbClr val="061F32"/>
                 </a:solidFill>
@@ -2373,27 +2307,16 @@
                 <a:ea typeface="微软雅黑"/>
                 <a:cs typeface="微软雅黑"/>
               </a:rPr>
-              <a:t>DKFZ 资深科学家、课题负责人</a:t>
-            </a:r>
-            <a:r>
-              <a:rPr lang="zh-CN" altLang="en-US" sz="1000">
-                <a:solidFill>
-                  <a:srgbClr val="44546A"/>
-                </a:solidFill>
-                <a:latin typeface="微软雅黑"/>
-                <a:ea typeface="微软雅黑"/>
-                <a:cs typeface="微软雅黑"/>
-              </a:rPr>
-              <a:t>；海德堡大学医院开展患者来源肿瘤类器官指导的个体化胶质母细胞瘤治疗研究</a:t>
-            </a:r>
-          </a:p>
-          <a:p>
-            <a:pPr algn="l" marL="171450" indent="-171450">
-              <a:lnSpc>
-                <a:spcPct val="112000"/>
+              <a:t>DKFZ 资深科学家 / PI</a:t>
+            </a:r>
+          </a:p>
+          <a:p>
+            <a:pPr marL="190500" indent="-190500">
+              <a:lnSpc>
+                <a:spcPct val="110000"/>
               </a:lnSpc>
               <a:spcAft>
-                <a:spcPts val="300"/>
+                <a:spcPts val="1000"/>
               </a:spcAft>
               <a:buClr>
                 <a:srgbClr val="08A6F6"/>
@@ -2402,7 +2325,7 @@
               <a:buChar char="•"/>
             </a:pPr>
             <a:r>
-              <a:rPr lang="zh-CN" altLang="en-US" sz="1000" b="1">
+              <a:rPr lang="zh-CN" altLang="en-US" sz="1400">
                 <a:solidFill>
                   <a:srgbClr val="061F32"/>
                 </a:solidFill>
@@ -2410,27 +2333,16 @@
                 <a:ea typeface="微软雅黑"/>
                 <a:cs typeface="微软雅黑"/>
               </a:rPr>
-              <a:t>第一作者成果 Science（修回中）、Cell（投稿中）</a:t>
-            </a:r>
-            <a:r>
-              <a:rPr lang="zh-CN" altLang="en-US" sz="1000">
-                <a:solidFill>
-                  <a:srgbClr val="44546A"/>
-                </a:solidFill>
-                <a:latin typeface="微软雅黑"/>
-                <a:ea typeface="微软雅黑"/>
-                <a:cs typeface="微软雅黑"/>
-              </a:rPr>
-              <a:t>；Cell Stem Cell 2025 等 19 篇论文</a:t>
-            </a:r>
-          </a:p>
-          <a:p>
-            <a:pPr algn="l" marL="171450" indent="-171450">
-              <a:lnSpc>
-                <a:spcPct val="112000"/>
+              <a:t>Science 修回｜19 篇论文</a:t>
+            </a:r>
+          </a:p>
+          <a:p>
+            <a:pPr marL="190500" indent="-190500">
+              <a:lnSpc>
+                <a:spcPct val="110000"/>
               </a:lnSpc>
               <a:spcAft>
-                <a:spcPts val="300"/>
+                <a:spcPts val="1000"/>
               </a:spcAft>
               <a:buClr>
                 <a:srgbClr val="08A6F6"/>
@@ -2439,7 +2351,7 @@
               <a:buChar char="•"/>
             </a:pPr>
             <a:r>
-              <a:rPr lang="zh-CN" altLang="en-US" sz="1000" b="1">
+              <a:rPr lang="zh-CN" altLang="en-US" sz="1400">
                 <a:solidFill>
                   <a:srgbClr val="061F32"/>
                 </a:solidFill>
@@ -2447,27 +2359,16 @@
                 <a:ea typeface="微软雅黑"/>
                 <a:cs typeface="微软雅黑"/>
               </a:rPr>
-              <a:t>参与 ERC、DFG、HFSP、NIH BRAIN Initiative</a:t>
-            </a:r>
-            <a:r>
-              <a:rPr lang="zh-CN" altLang="en-US" sz="1000">
-                <a:solidFill>
-                  <a:srgbClr val="44546A"/>
-                </a:solidFill>
-                <a:latin typeface="微软雅黑"/>
-                <a:ea typeface="微软雅黑"/>
-                <a:cs typeface="微软雅黑"/>
-              </a:rPr>
-              <a:t>及国家 973 / 863 等重大项目</a:t>
-            </a:r>
-          </a:p>
-          <a:p>
-            <a:pPr algn="l" marL="171450" indent="-171450">
-              <a:lnSpc>
-                <a:spcPct val="112000"/>
+              <a:t>患者类器官个体化治疗</a:t>
+            </a:r>
+          </a:p>
+          <a:p>
+            <a:pPr marL="190500" indent="-190500">
+              <a:lnSpc>
+                <a:spcPct val="110000"/>
               </a:lnSpc>
               <a:spcAft>
-                <a:spcPts val="300"/>
+                <a:spcPts val="1000"/>
               </a:spcAft>
               <a:buClr>
                 <a:srgbClr val="08A6F6"/>
@@ -2476,7 +2377,7 @@
               <a:buChar char="•"/>
             </a:pPr>
             <a:r>
-              <a:rPr lang="zh-CN" altLang="en-US" sz="1000" b="1">
+              <a:rPr lang="zh-CN" altLang="en-US" sz="1400">
                 <a:solidFill>
                   <a:srgbClr val="061F32"/>
                 </a:solidFill>
@@ -2484,18 +2385,7 @@
                 <a:ea typeface="微软雅黑"/>
                 <a:cs typeface="微软雅黑"/>
               </a:rPr>
-              <a:t>Neusician 首席神经科学官</a:t>
-            </a:r>
-            <a:r>
-              <a:rPr lang="zh-CN" altLang="en-US" sz="1000">
-                <a:solidFill>
-                  <a:srgbClr val="44546A"/>
-                </a:solidFill>
-                <a:latin typeface="微软雅黑"/>
-                <a:ea typeface="微软雅黑"/>
-                <a:cs typeface="微软雅黑"/>
-              </a:rPr>
-              <a:t>；慕尼黑大学 / 亥姆霍兹中心神经生物学博士</a:t>
+              <a:t>慕尼黑大学 / 亥姆霍兹博士</a:t>
             </a:r>
           </a:p>
         </p:txBody>
@@ -2695,12 +2585,12 @@
           </a:bodyPr>
           <a:lstStyle/>
           <a:p>
-            <a:pPr algn="l" marL="171450" indent="-171450">
-              <a:lnSpc>
-                <a:spcPct val="112000"/>
+            <a:pPr marL="190500" indent="-190500">
+              <a:lnSpc>
+                <a:spcPct val="110000"/>
               </a:lnSpc>
               <a:spcAft>
-                <a:spcPts val="300"/>
+                <a:spcPts val="1000"/>
               </a:spcAft>
               <a:buClr>
                 <a:srgbClr val="08A6F6"/>
@@ -2709,7 +2599,7 @@
               <a:buChar char="•"/>
             </a:pPr>
             <a:r>
-              <a:rPr lang="zh-CN" altLang="en-US" sz="1000" b="1">
+              <a:rPr lang="zh-CN" altLang="en-US" sz="1400">
                 <a:solidFill>
                   <a:srgbClr val="061F32"/>
                 </a:solidFill>
@@ -2717,27 +2607,16 @@
                 <a:ea typeface="微软雅黑"/>
                 <a:cs typeface="微软雅黑"/>
               </a:rPr>
-              <a:t>慕尼黑工业大学 / 慕尼黑亥姆霍兹中心生物信息学博士</a:t>
-            </a:r>
-            <a:r>
-              <a:rPr lang="zh-CN" altLang="en-US" sz="1000">
-                <a:solidFill>
-                  <a:srgbClr val="44546A"/>
-                </a:solidFill>
-                <a:latin typeface="微软雅黑"/>
-                <a:ea typeface="微软雅黑"/>
-                <a:cs typeface="微软雅黑"/>
-              </a:rPr>
-              <a:t>；厦门大学硕士</a:t>
-            </a:r>
-          </a:p>
-          <a:p>
-            <a:pPr algn="l" marL="171450" indent="-171450">
-              <a:lnSpc>
-                <a:spcPct val="112000"/>
+              <a:t>慕尼黑工大 / 亥姆霍兹博士</a:t>
+            </a:r>
+          </a:p>
+          <a:p>
+            <a:pPr marL="190500" indent="-190500">
+              <a:lnSpc>
+                <a:spcPct val="110000"/>
               </a:lnSpc>
               <a:spcAft>
-                <a:spcPts val="300"/>
+                <a:spcPts val="1000"/>
               </a:spcAft>
               <a:buClr>
                 <a:srgbClr val="08A6F6"/>
@@ -2746,7 +2625,7 @@
               <a:buChar char="•"/>
             </a:pPr>
             <a:r>
-              <a:rPr lang="zh-CN" altLang="en-US" sz="1000" b="1">
+              <a:rPr lang="zh-CN" altLang="en-US" sz="1400">
                 <a:solidFill>
                   <a:srgbClr val="061F32"/>
                 </a:solidFill>
@@ -2754,27 +2633,16 @@
                 <a:ea typeface="微软雅黑"/>
                 <a:cs typeface="微软雅黑"/>
               </a:rPr>
-              <a:t>约 10 年生物信息与多组学分析经验</a:t>
-            </a:r>
-            <a:r>
-              <a:rPr lang="zh-CN" altLang="en-US" sz="1000">
-                <a:solidFill>
-                  <a:srgbClr val="44546A"/>
-                </a:solidFill>
-                <a:latin typeface="微软雅黑"/>
-                <a:ea typeface="微软雅黑"/>
-                <a:cs typeface="微软雅黑"/>
-              </a:rPr>
-              <a:t>；曾任职哈佛医学院，负责临床试验数据与多组学预测建模</a:t>
-            </a:r>
-          </a:p>
-          <a:p>
-            <a:pPr algn="l" marL="171450" indent="-171450">
-              <a:lnSpc>
-                <a:spcPct val="112000"/>
+              <a:t>曾任职哈佛医学院</a:t>
+            </a:r>
+          </a:p>
+          <a:p>
+            <a:pPr marL="190500" indent="-190500">
+              <a:lnSpc>
+                <a:spcPct val="110000"/>
               </a:lnSpc>
               <a:spcAft>
-                <a:spcPts val="300"/>
+                <a:spcPts val="1000"/>
               </a:spcAft>
               <a:buClr>
                 <a:srgbClr val="08A6F6"/>
@@ -2783,7 +2651,7 @@
               <a:buChar char="•"/>
             </a:pPr>
             <a:r>
-              <a:rPr lang="zh-CN" altLang="en-US" sz="1000" b="1">
+              <a:rPr lang="zh-CN" altLang="en-US" sz="1400">
                 <a:solidFill>
                   <a:srgbClr val="061F32"/>
                 </a:solidFill>
@@ -2791,27 +2659,16 @@
                 <a:ea typeface="微软雅黑"/>
                 <a:cs typeface="微软雅黑"/>
               </a:rPr>
-              <a:t>预测模型 AUC &gt; 0.95</a:t>
-            </a:r>
-            <a:r>
-              <a:rPr lang="zh-CN" altLang="en-US" sz="1000">
-                <a:solidFill>
-                  <a:srgbClr val="44546A"/>
-                </a:solidFill>
-                <a:latin typeface="微软雅黑"/>
-                <a:ea typeface="微软雅黑"/>
-                <a:cs typeface="微软雅黑"/>
-              </a:rPr>
-              <a:t>（高维数据分类）；临床多组学预测 AUC &gt; 0.80</a:t>
-            </a:r>
-          </a:p>
-          <a:p>
-            <a:pPr algn="l" marL="171450" indent="-171450">
-              <a:lnSpc>
-                <a:spcPct val="112000"/>
+              <a:t>10 年多组学分析</a:t>
+            </a:r>
+          </a:p>
+          <a:p>
+            <a:pPr marL="190500" indent="-190500">
+              <a:lnSpc>
+                <a:spcPct val="110000"/>
               </a:lnSpc>
               <a:spcAft>
-                <a:spcPts val="300"/>
+                <a:spcPts val="1000"/>
               </a:spcAft>
               <a:buClr>
                 <a:srgbClr val="08A6F6"/>
@@ -2820,7 +2677,7 @@
               <a:buChar char="•"/>
             </a:pPr>
             <a:r>
-              <a:rPr lang="zh-CN" altLang="en-US" sz="1000" b="1">
+              <a:rPr lang="zh-CN" altLang="en-US" sz="1400">
                 <a:solidFill>
                   <a:srgbClr val="061F32"/>
                 </a:solidFill>
@@ -2828,27 +2685,16 @@
                 <a:ea typeface="微软雅黑"/>
                 <a:cs typeface="微软雅黑"/>
               </a:rPr>
-              <a:t>多模态 + 纵向数据整合</a:t>
-            </a:r>
-            <a:r>
-              <a:rPr lang="zh-CN" altLang="en-US" sz="1000">
-                <a:solidFill>
-                  <a:srgbClr val="44546A"/>
-                </a:solidFill>
-                <a:latin typeface="微软雅黑"/>
-                <a:ea typeface="微软雅黑"/>
-                <a:cs typeface="微软雅黑"/>
-              </a:rPr>
-              <a:t>：测序、转录、代谢、表型与临床元数据</a:t>
-            </a:r>
-          </a:p>
-          <a:p>
-            <a:pPr algn="l" marL="171450" indent="-171450">
-              <a:lnSpc>
-                <a:spcPct val="112000"/>
+              <a:t>预测模型 AUC &gt; 0.95</a:t>
+            </a:r>
+          </a:p>
+          <a:p>
+            <a:pPr marL="190500" indent="-190500">
+              <a:lnSpc>
+                <a:spcPct val="110000"/>
               </a:lnSpc>
               <a:spcAft>
-                <a:spcPts val="300"/>
+                <a:spcPts val="1000"/>
               </a:spcAft>
               <a:buClr>
                 <a:srgbClr val="08A6F6"/>
@@ -2857,7 +2703,7 @@
               <a:buChar char="•"/>
             </a:pPr>
             <a:r>
-              <a:rPr lang="zh-CN" altLang="en-US" sz="1000" b="1">
+              <a:rPr lang="zh-CN" altLang="en-US" sz="1400">
                 <a:solidFill>
                   <a:srgbClr val="061F32"/>
                 </a:solidFill>
@@ -2865,18 +2711,7 @@
                 <a:ea typeface="微软雅黑"/>
                 <a:cs typeface="微软雅黑"/>
               </a:rPr>
-              <a:t>HPC / SLURM 规模化分析流程</a:t>
-            </a:r>
-            <a:r>
-              <a:rPr lang="zh-CN" altLang="en-US" sz="1000">
-                <a:solidFill>
-                  <a:srgbClr val="44546A"/>
-                </a:solidFill>
-                <a:latin typeface="微软雅黑"/>
-                <a:ea typeface="微软雅黑"/>
-                <a:cs typeface="微软雅黑"/>
-              </a:rPr>
-              <a:t>，单批覆盖数百至数千样本</a:t>
+              <a:t>多模态 × 规模化计算</a:t>
             </a:r>
           </a:p>
         </p:txBody>
@@ -3076,12 +2911,12 @@
           </a:bodyPr>
           <a:lstStyle/>
           <a:p>
-            <a:pPr algn="l" marL="171450" indent="-171450">
-              <a:lnSpc>
-                <a:spcPct val="112000"/>
+            <a:pPr marL="190500" indent="-190500">
+              <a:lnSpc>
+                <a:spcPct val="110000"/>
               </a:lnSpc>
               <a:spcAft>
-                <a:spcPts val="300"/>
+                <a:spcPts val="1000"/>
               </a:spcAft>
               <a:buClr>
                 <a:srgbClr val="08A6F6"/>
@@ -3090,7 +2925,7 @@
               <a:buChar char="•"/>
             </a:pPr>
             <a:r>
-              <a:rPr lang="zh-CN" altLang="en-US" sz="1000" b="1">
+              <a:rPr lang="zh-CN" altLang="en-US" sz="1400">
                 <a:solidFill>
                   <a:srgbClr val="061F32"/>
                 </a:solidFill>
@@ -3098,27 +2933,16 @@
                 <a:ea typeface="微软雅黑"/>
                 <a:cs typeface="微软雅黑"/>
               </a:rPr>
-              <a:t>德国商业银行（Commerzbank）高级合规官</a:t>
-            </a:r>
-            <a:r>
-              <a:rPr lang="zh-CN" altLang="en-US" sz="1000">
-                <a:solidFill>
-                  <a:srgbClr val="44546A"/>
-                </a:solidFill>
-                <a:latin typeface="微软雅黑"/>
-                <a:ea typeface="微软雅黑"/>
-                <a:cs typeface="微软雅黑"/>
-              </a:rPr>
-              <a:t>：统筹集团全球分支风控合规，向董事会提交风险研判</a:t>
-            </a:r>
-          </a:p>
-          <a:p>
-            <a:pPr algn="l" marL="171450" indent="-171450">
-              <a:lnSpc>
-                <a:spcPct val="112000"/>
+              <a:t>德国商业银行高级合规官</a:t>
+            </a:r>
+          </a:p>
+          <a:p>
+            <a:pPr marL="190500" indent="-190500">
+              <a:lnSpc>
+                <a:spcPct val="110000"/>
               </a:lnSpc>
               <a:spcAft>
-                <a:spcPts val="300"/>
+                <a:spcPts val="1000"/>
               </a:spcAft>
               <a:buClr>
                 <a:srgbClr val="08A6F6"/>
@@ -3127,7 +2951,7 @@
               <a:buChar char="•"/>
             </a:pPr>
             <a:r>
-              <a:rPr lang="zh-CN" altLang="en-US" sz="1000" b="1">
+              <a:rPr lang="zh-CN" altLang="en-US" sz="1400">
                 <a:solidFill>
                   <a:srgbClr val="061F32"/>
                 </a:solidFill>
@@ -3135,27 +2959,16 @@
                 <a:ea typeface="微软雅黑"/>
                 <a:cs typeface="微软雅黑"/>
               </a:rPr>
-              <a:t>曾任 Sopra Steria 合规官</a:t>
-            </a:r>
-            <a:r>
-              <a:rPr lang="zh-CN" altLang="en-US" sz="1000">
-                <a:solidFill>
-                  <a:srgbClr val="44546A"/>
-                </a:solidFill>
-                <a:latin typeface="微软雅黑"/>
-                <a:ea typeface="微软雅黑"/>
-                <a:cs typeface="微软雅黑"/>
-              </a:rPr>
-              <a:t>、中国银行法兰克福分行反洗钱分析师</a:t>
-            </a:r>
-          </a:p>
-          <a:p>
-            <a:pPr algn="l" marL="171450" indent="-171450">
-              <a:lnSpc>
-                <a:spcPct val="112000"/>
+              <a:t>中国银行法兰克福分行</a:t>
+            </a:r>
+          </a:p>
+          <a:p>
+            <a:pPr marL="190500" indent="-190500">
+              <a:lnSpc>
+                <a:spcPct val="110000"/>
               </a:lnSpc>
               <a:spcAft>
-                <a:spcPts val="300"/>
+                <a:spcPts val="1000"/>
               </a:spcAft>
               <a:buClr>
                 <a:srgbClr val="08A6F6"/>
@@ -3164,7 +2977,7 @@
               <a:buChar char="•"/>
             </a:pPr>
             <a:r>
-              <a:rPr lang="zh-CN" altLang="en-US" sz="1000" b="1">
+              <a:rPr lang="zh-CN" altLang="en-US" sz="1400">
                 <a:solidFill>
                   <a:srgbClr val="061F32"/>
                 </a:solidFill>
@@ -3172,27 +2985,16 @@
                 <a:ea typeface="微软雅黑"/>
                 <a:cs typeface="微软雅黑"/>
               </a:rPr>
-              <a:t>歌德商学院高管教育中心高级项目经理</a:t>
-            </a:r>
-            <a:r>
-              <a:rPr lang="zh-CN" altLang="en-US" sz="1000">
-                <a:solidFill>
-                  <a:srgbClr val="44546A"/>
-                </a:solidFill>
-                <a:latin typeface="微软雅黑"/>
-                <a:ea typeface="微软雅黑"/>
-                <a:cs typeface="微软雅黑"/>
-              </a:rPr>
-              <a:t>：搭建中德企业家与科创创始人交流平台</a:t>
-            </a:r>
-          </a:p>
-          <a:p>
-            <a:pPr algn="l" marL="171450" indent="-171450">
-              <a:lnSpc>
-                <a:spcPct val="112000"/>
+              <a:t>FRM｜CFA 一级</a:t>
+            </a:r>
+          </a:p>
+          <a:p>
+            <a:pPr marL="190500" indent="-190500">
+              <a:lnSpc>
+                <a:spcPct val="110000"/>
               </a:lnSpc>
               <a:spcAft>
-                <a:spcPts val="300"/>
+                <a:spcPts val="1000"/>
               </a:spcAft>
               <a:buClr>
                 <a:srgbClr val="08A6F6"/>
@@ -3201,7 +3003,7 @@
               <a:buChar char="•"/>
             </a:pPr>
             <a:r>
-              <a:rPr lang="zh-CN" altLang="en-US" sz="1000" b="1">
+              <a:rPr lang="zh-CN" altLang="en-US" sz="1400">
                 <a:solidFill>
                   <a:srgbClr val="061F32"/>
                 </a:solidFill>
@@ -3209,27 +3011,16 @@
                 <a:ea typeface="微软雅黑"/>
                 <a:cs typeface="微软雅黑"/>
               </a:rPr>
-              <a:t>FRM、ESG Investing 认证</a:t>
-            </a:r>
-            <a:r>
-              <a:rPr lang="zh-CN" altLang="en-US" sz="1000">
-                <a:solidFill>
-                  <a:srgbClr val="44546A"/>
-                </a:solidFill>
-                <a:latin typeface="微软雅黑"/>
-                <a:ea typeface="微软雅黑"/>
-                <a:cs typeface="微软雅黑"/>
-              </a:rPr>
-              <a:t>；CFA 一级；精通英语、德语</a:t>
-            </a:r>
-          </a:p>
-          <a:p>
-            <a:pPr algn="l" marL="171450" indent="-171450">
-              <a:lnSpc>
-                <a:spcPct val="112000"/>
+              <a:t>海德堡大学经济学硕士</a:t>
+            </a:r>
+          </a:p>
+          <a:p>
+            <a:pPr marL="190500" indent="-190500">
+              <a:lnSpc>
+                <a:spcPct val="110000"/>
               </a:lnSpc>
               <a:spcAft>
-                <a:spcPts val="300"/>
+                <a:spcPts val="1000"/>
               </a:spcAft>
               <a:buClr>
                 <a:srgbClr val="08A6F6"/>
@@ -3238,7 +3029,7 @@
               <a:buChar char="•"/>
             </a:pPr>
             <a:r>
-              <a:rPr lang="zh-CN" altLang="en-US" sz="1000" b="1">
+              <a:rPr lang="zh-CN" altLang="en-US" sz="1400">
                 <a:solidFill>
                   <a:srgbClr val="061F32"/>
                 </a:solidFill>
@@ -3246,18 +3037,7 @@
                 <a:ea typeface="微软雅黑"/>
                 <a:cs typeface="微软雅黑"/>
               </a:rPr>
-              <a:t>海德堡大学经济学硕士</a:t>
-            </a:r>
-            <a:r>
-              <a:rPr lang="zh-CN" altLang="en-US" sz="1000">
-                <a:solidFill>
-                  <a:srgbClr val="44546A"/>
-                </a:solidFill>
-                <a:latin typeface="微软雅黑"/>
-                <a:ea typeface="微软雅黑"/>
-                <a:cs typeface="微软雅黑"/>
-              </a:rPr>
-              <a:t>；浙江大学管理学学士（竺可桢学院创新与创业管理强化班）</a:t>
+              <a:t>浙大竺可桢学院</a:t>
             </a:r>
           </a:p>
         </p:txBody>

</xml_diff>